<commit_message>
Incorpora en el informe la evidencia de k6, ZAP, Trivy y npm audit.
</commit_message>
<xml_diff>
--- a/entrega/Presentacion_EP4_Atlas.pptx
+++ b/entrega/Presentacion_EP4_Atlas.pptx
@@ -3263,7 +3263,7 @@
                   <a:schemeClr val="tx1"/>
                 </a:solidFill>
               </a:rPr>
-              <a:t>NFR-PERF-3 no se corrió</a:t>
+              <a:t>200 usuarios durante 20 segundos</a:t>
             </a:r>
             <a:endParaRPr lang="en-US" sz="1300" dirty="0"/>
           </a:p>
@@ -3335,7 +3335,7 @@
                   <a:schemeClr val="tx1"/>
                 </a:solidFill>
               </a:rPr>
-              <a:t>No hay p95 ni prueba de concurrencia</a:t>
+              <a:t>p95 = 1,28 s, sobre 300 ms</a:t>
             </a:r>
             <a:endParaRPr lang="en-US" sz="1300" dirty="0"/>
           </a:p>
@@ -3407,7 +3407,7 @@
                   <a:schemeClr val="tx1"/>
                 </a:solidFill>
               </a:rPr>
-              <a:t>Queda abierto como INC-02</a:t>
+              <a:t>INC-02 abierto: no cumple</a:t>
             </a:r>
             <a:endParaRPr lang="en-US" sz="1300" dirty="0"/>
           </a:p>
@@ -3857,7 +3857,7 @@
                   <a:schemeClr val="accent5"/>
                 </a:solidFill>
               </a:rPr>
-              <a:t>Se informa la carga no ejecutada</a:t>
+              <a:t>Se informa el p95 de 1,28 s</a:t>
             </a:r>
             <a:endParaRPr lang="en-US" sz="1200" dirty="0"/>
           </a:p>
@@ -4708,7 +4708,7 @@
                   <a:schemeClr val="tx1"/>
                 </a:solidFill>
               </a:rPr>
-              <a:t>Ejecutar la carga de 200 usuarios</a:t>
+              <a:t>Bajar el p95 bajo 300 ms</a:t>
             </a:r>
             <a:endParaRPr lang="en-US" sz="1600" dirty="0"/>
           </a:p>
@@ -5260,7 +5260,7 @@
                   <a:schemeClr val="tx1"/>
                 </a:solidFill>
               </a:rPr>
-              <a:t>Correr npm audit y Trivy</a:t>
+              <a:t>Parchear Express y las cabeceras</a:t>
             </a:r>
             <a:endParaRPr lang="en-US" sz="1600" dirty="0"/>
           </a:p>
@@ -5751,7 +5751,7 @@
                   <a:schemeClr val="bg2"/>
                 </a:solidFill>
               </a:rPr>
-              <a:t>La carga de 200 usuarios y el TLS siguen abiertos</a:t>
+              <a:t>Siguen abiertos el p95 y el TLS</a:t>
             </a:r>
             <a:endParaRPr lang="en-US" sz="1400" dirty="0"/>
           </a:p>
@@ -5882,7 +5882,7 @@
                   <a:schemeClr val="bg1"/>
                 </a:solidFill>
               </a:rPr>
-              <a:t>Pendiente: NFR-PERF-3 y TLS fuera de localhost</a:t>
+              <a:t>Pendiente: p95 de 300 ms, TLS y CVE</a:t>
             </a:r>
             <a:endParaRPr lang="en-US" sz="1400" dirty="0"/>
           </a:p>
@@ -8532,7 +8532,7 @@
                   <a:schemeClr val="bg1"/>
                 </a:solidFill>
               </a:rPr>
-              <a:t>Login, 403, baja lógica y documento</a:t>
+              <a:t>Login, 403, baja, documento y k6</a:t>
             </a:r>
             <a:endParaRPr lang="en-US" sz="1400" dirty="0"/>
           </a:p>
@@ -8550,7 +8550,7 @@
                   <a:schemeClr val="bg1"/>
                 </a:solidFill>
               </a:rPr>
-              <a:t>Evidencia HTTP del 17-10-2026</a:t>
+              <a:t>Evidencia del 17-10-2026</a:t>
             </a:r>
             <a:endParaRPr lang="en-US" sz="1400" dirty="0"/>
           </a:p>
@@ -9741,7 +9741,7 @@
                   <a:schemeClr val="tx1"/>
                 </a:solidFill>
               </a:rPr>
-              <a:t>403 del editor · baja lógica · evidencia anexada</a:t>
+              <a:t>403 · baja lógica · k6 p95 1,28 s</a:t>
             </a:r>
             <a:endParaRPr lang="en-US" sz="1400" dirty="0"/>
           </a:p>
@@ -10685,7 +10685,7 @@
                             <a:srgbClr val="10222B"/>
                           </a:solidFill>
                         </a:rPr>
-                        <a:t>Carga 200</a:t>
+                        <a:t>k6, 200 usuarios</a:t>
                       </a:r>
                       <a:endParaRPr lang="en-US" sz="1200" dirty="0"/>
                     </a:p>
@@ -10759,7 +10759,7 @@
                             <a:srgbClr val="10222B"/>
                           </a:solidFill>
                         </a:rPr>
-                        <a:t>No se conoce el p95</a:t>
+                        <a:t>Sin la medición no hay p95</a:t>
                       </a:r>
                       <a:endParaRPr lang="en-US" sz="1200" dirty="0"/>
                     </a:p>
@@ -12395,7 +12395,7 @@
                   <a:schemeClr val="accent5"/>
                 </a:solidFill>
               </a:rPr>
-              <a:t>Cada control cubre un requisito del ERS</a:t>
+              <a:t>k6, ZAP, npm audit y Trivy quedaron anexados</a:t>
             </a:r>
             <a:endParaRPr lang="en-US" sz="1200" dirty="0"/>
           </a:p>
@@ -13281,7 +13281,7 @@
                 <a:ea typeface="Cambria" pitchFamily="34" charset="-122"/>
                 <a:cs typeface="Cambria" pitchFamily="34" charset="-120"/>
               </a:rPr>
-              <a:t>409</a:t>
+              <a:t>403</a:t>
             </a:r>
             <a:endParaRPr lang="en-US" sz="2600" dirty="0"/>
           </a:p>
@@ -13382,7 +13382,7 @@
                 <a:ea typeface="Cambria" pitchFamily="34" charset="-122"/>
                 <a:cs typeface="Cambria" pitchFamily="34" charset="-120"/>
               </a:rPr>
-              <a:t>204</a:t>
+              <a:t>200</a:t>
             </a:r>
             <a:endParaRPr lang="en-US" sz="2600" dirty="0"/>
           </a:p>
@@ -14095,7 +14095,7 @@
                   <a:schemeClr val="bg1"/>
                 </a:solidFill>
               </a:rPr>
-              <a:t>salud HTTP 200 en /api/salud</a:t>
+              <a:t>Trivy: 0 críticas en Alpine</a:t>
             </a:r>
             <a:endParaRPr lang="en-US" sz="1300" dirty="0"/>
           </a:p>

</xml_diff>